<commit_message>
Update Takagi deck with confirmed company facts (painting/renovation)
Confirmed 高城株式会社 from official site (takajyou.amebaownd.com):
Hiratsuka-based architectural painting/waterproofing/renovation
contractor ('NO PAINT, NO LIFE.', license 神奈川県知事 No.85139, rep
小早川和廉). Reframed the deck from a generic real-estate brokerage
assumption to the actual painting/renovation business: 物件/相続/重説
-> 現場/塗り替え再提案/見積・施工計画. Added the ~10-year repaint-cycle
angle (DB of past jobs -> proactive repeat-sales) as a why-now driver.
Fixed compliance refs (宅建業法 -> 建設業法等). README updated with
verified facts and sources.

Co-Authored-By: Claude Opus 4.8 <noreply@anthropic.com>
Claude-Session: https://claude.ai/code/session_01FgPSc7k4YFwo6oQWoKzRnP
</commit_message>
<xml_diff>
--- a/sales-materials/takagi-designworks/高城_デザインワークス様_AI構想提案_叩き台.pptx
+++ b/sales-materials/takagi-designworks/高城_デザインワークス様_AI構想提案_叩き台.pptx
@@ -4811,7 +4811,7 @@
                 <a:ea typeface="Meiryo"/>
                 <a:cs typeface="Meiryo"/>
               </a:rPr>
-              <a:t>まず何の書類・どの物件群から始めるか？（一番困っている / 一番数が多い）</a:t>
+              <a:t>まず何の書類・どの案件群から始めるか？（一番困っている / 一番数が多い）</a:t>
             </a:r>
           </a:p>
         </p:txBody>
@@ -4991,7 +4991,7 @@
                 <a:ea typeface="Meiryo"/>
                 <a:cs typeface="Meiryo"/>
               </a:rPr>
-              <a:t>図面・顧客情報は今どんな形式か？（紙・PDF・既存システム・Excel）</a:t>
+              <a:t>図面・見積・顧客情報は今どんな形式か？（紙・PDF・既存システム・Excel）</a:t>
             </a:r>
           </a:p>
         </p:txBody>
@@ -5351,7 +5351,7 @@
                 <a:ea typeface="Meiryo"/>
                 <a:cs typeface="Meiryo"/>
               </a:rPr>
-              <a:t>“移行”の先に何をしたいか？（検索・再提案・営業・相続対応…優先順位）</a:t>
+              <a:t>“移行”の先に何をしたいか？（検索・塗り替え再提案・営業活用…優先順位）</a:t>
             </a:r>
           </a:p>
         </p:txBody>
@@ -9350,14 +9350,14 @@
           <a:p>
             <a:pPr algn="l">
               <a:lnSpc>
-                <a:spcPct val="145000"/>
+                <a:spcPct val="140000"/>
               </a:lnSpc>
               <a:spcAft>
                 <a:spcPts val="800"/>
               </a:spcAft>
             </a:pPr>
             <a:r>
-              <a:rPr sz="1300" b="0">
+              <a:rPr sz="1250" b="0">
                 <a:solidFill>
                   <a:srgbClr val="6A7178"/>
                 </a:solidFill>
@@ -9365,20 +9365,20 @@
                 <a:ea typeface="Meiryo"/>
                 <a:cs typeface="Meiryo"/>
               </a:rPr>
-              <a:t>高城株式会社（不動産）と株式会社デザインワークス（設計）が連携し、建設・不動産を一気通貫で手がけるグループ、と理解しています。</a:t>
+              <a:t>高城株式会社は神奈川県平塚市を拠点に、建築塗装・防水・改修工事を手がける会社（許可：神奈川県知事 第85139号、代表 小早川和廉様、「NO PAINT, NO LIFE.」）。</a:t>
             </a:r>
           </a:p>
           <a:p>
             <a:pPr algn="l">
               <a:lnSpc>
-                <a:spcPct val="145000"/>
+                <a:spcPct val="140000"/>
               </a:lnSpc>
               <a:spcAft>
                 <a:spcPts val="800"/>
               </a:spcAft>
             </a:pPr>
             <a:r>
-              <a:rPr sz="1300" b="0">
+              <a:rPr sz="1250" b="0">
                 <a:solidFill>
                   <a:srgbClr val="6A7178"/>
                 </a:solidFill>
@@ -9386,10 +9386,31 @@
                 <a:ea typeface="Meiryo"/>
                 <a:cs typeface="Meiryo"/>
               </a:rPr>
-              <a:t>従業員110〜120名規模で、すでに一部社員がAIを活用し、公開APIも取り入れている——</a:t>
-            </a:r>
-            <a:r>
-              <a:rPr sz="1300" b="1">
+              <a:t>株式会社デザインワークス（設計・デザイン）と連携し、塗装・改修から設計まで一気通貫で対応するグループ、と理解しています。</a:t>
+            </a:r>
+          </a:p>
+          <a:p>
+            <a:pPr algn="l">
+              <a:lnSpc>
+                <a:spcPct val="140000"/>
+              </a:lnSpc>
+              <a:spcAft>
+                <a:spcPts val="800"/>
+              </a:spcAft>
+            </a:pPr>
+            <a:r>
+              <a:rPr sz="1250" b="0">
+                <a:solidFill>
+                  <a:srgbClr val="6A7178"/>
+                </a:solidFill>
+                <a:latin typeface="Meiryo"/>
+                <a:ea typeface="Meiryo"/>
+                <a:cs typeface="Meiryo"/>
+              </a:rPr>
+              <a:t>従業員110〜120名・AI活用も着手済み——</a:t>
+            </a:r>
+            <a:r>
+              <a:rPr sz="1250" b="1">
                 <a:solidFill>
                   <a:srgbClr val="283845"/>
                 </a:solidFill>
@@ -9400,28 +9421,7 @@
               <a:t>“使える組織”の土台はすでにある</a:t>
             </a:r>
             <a:r>
-              <a:rPr sz="1300" b="0">
-                <a:solidFill>
-                  <a:srgbClr val="6A7178"/>
-                </a:solidFill>
-                <a:latin typeface="Meiryo"/>
-                <a:ea typeface="Meiryo"/>
-                <a:cs typeface="Meiryo"/>
-              </a:rPr>
-              <a:t>状態です。</a:t>
-            </a:r>
-          </a:p>
-          <a:p>
-            <a:pPr algn="l">
-              <a:lnSpc>
-                <a:spcPct val="145000"/>
-              </a:lnSpc>
-              <a:spcAft>
-                <a:spcPts val="800"/>
-              </a:spcAft>
-            </a:pPr>
-            <a:r>
-              <a:rPr sz="1350" b="1">
+              <a:rPr sz="1250" b="1">
                 <a:solidFill>
                   <a:srgbClr val="283845"/>
                 </a:solidFill>
@@ -9429,7 +9429,7 @@
                 <a:ea typeface="Meiryo"/>
                 <a:cs typeface="Meiryo"/>
               </a:rPr>
-              <a:t>次の一手は、現場の小技ではなく“設計×顧客情報”という会社の資産そのものをAIで活かすこと。</a:t>
+              <a:t>。次の一手は、過去の施工・設計・顧客情報という会社の資産をAIで活かすことです。</a:t>
             </a:r>
           </a:p>
         </p:txBody>
@@ -9668,7 +9668,7 @@
                 <a:ea typeface="Meiryo"/>
                 <a:cs typeface="Meiryo"/>
               </a:rPr>
-              <a:t>2</a:t>
+              <a:t>塗装×設計</a:t>
             </a:r>
             <a:r>
               <a:rPr sz="1300" b="1">
@@ -9679,7 +9679,7 @@
                 <a:ea typeface="Meiryo"/>
                 <a:cs typeface="Meiryo"/>
               </a:rPr>
-              <a:t>社</a:t>
+              <a:t/>
             </a:r>
           </a:p>
         </p:txBody>
@@ -9723,7 +9723,7 @@
                 <a:ea typeface="Meiryo"/>
                 <a:cs typeface="Meiryo"/>
               </a:rPr>
-              <a:t>不動産 × 設計</a:t>
+              <a:t>2社グループ</a:t>
             </a:r>
           </a:p>
         </p:txBody>
@@ -9962,7 +9962,7 @@
                 <a:ea typeface="Meiryo"/>
                 <a:cs typeface="Meiryo"/>
               </a:rPr>
-              <a:t>設計×個人情報</a:t>
+              <a:t>施工×個人情報</a:t>
             </a:r>
             <a:r>
               <a:rPr sz="1300" b="1">
@@ -10668,7 +10668,7 @@
                 <a:ea typeface="Meiryo"/>
                 <a:cs typeface="Meiryo"/>
               </a:rPr>
-              <a:t>紙・PDFの図面、契約書、重要事項説明書、顧客台帳に、設計情報と個人情報が“バラバラ・属人的”に眠っている</a:t>
+              <a:t>紙・PDFの図面、見積書、施工写真、顧客台帳に、施工・設計情報と個人情報が“バラバラ・属人的”に眠っている</a:t>
             </a:r>
           </a:p>
         </p:txBody>
@@ -10848,7 +10848,7 @@
                 <a:ea typeface="Meiryo"/>
                 <a:cs typeface="Meiryo"/>
               </a:rPr>
-              <a:t>AI-OCR＋情報抽出で、図面のメタ情報と顧客の個人情報を読み取り、構造化データに変換</a:t>
+              <a:t>AI-OCR＋情報抽出で、図面・施工のメタ情報と顧客の個人情報を読み取り、構造化データに変換</a:t>
             </a:r>
           </a:p>
         </p:txBody>
@@ -11028,7 +11028,7 @@
                 <a:ea typeface="Meiryo"/>
                 <a:cs typeface="Meiryo"/>
               </a:rPr>
-              <a:t>物件・設計・顧客が紐づいた検索可能なDBへ。「この土地の過去設計は？」に即答できる資産に</a:t>
+              <a:t>現場・設計・顧客が紐づいた検索可能なDBへ。「あの現場の前回施工は？」に即答できる資産に</a:t>
             </a:r>
           </a:p>
         </p:txBody>
@@ -11578,7 +11578,7 @@
                 <a:ea typeface="Meiryo"/>
                 <a:cs typeface="Meiryo"/>
               </a:rPr>
-              <a:t>過去物件・図面・顧客履歴が探せず、問い合わせや再提案に時間がかかる</a:t>
+              <a:t>過去の現場・図面・顧客履歴が探せず、問い合わせや再提案に時間がかかる</a:t>
             </a:r>
           </a:p>
         </p:txBody>
@@ -11670,7 +11670,7 @@
                 <a:ea typeface="Meiryo"/>
                 <a:cs typeface="Meiryo"/>
               </a:rPr>
-              <a:t>👤</a:t>
+              <a:t>🔁</a:t>
             </a:r>
           </a:p>
         </p:txBody>
@@ -11714,7 +11714,7 @@
                 <a:ea typeface="Meiryo"/>
                 <a:cs typeface="Meiryo"/>
               </a:rPr>
-              <a:t>属人化・退職リスク</a:t>
+              <a:t>塗り替え再提案の機会損失</a:t>
             </a:r>
           </a:p>
         </p:txBody>
@@ -11758,7 +11758,7 @@
                 <a:ea typeface="Meiryo"/>
                 <a:cs typeface="Meiryo"/>
               </a:rPr>
-              <a:t>“あの人しか知らない”状態。ベテラン退職で情報ごと失われる</a:t>
+              <a:t>塗装・防水は約10年周期の塗り替え需要。施工履歴がDB化されていれば“次の塗り替え”を先回り提案できる</a:t>
             </a:r>
           </a:p>
         </p:txBody>
@@ -11850,7 +11850,7 @@
                 <a:ea typeface="Meiryo"/>
                 <a:cs typeface="Meiryo"/>
               </a:rPr>
-              <a:t>📑</a:t>
+              <a:t>👤</a:t>
             </a:r>
           </a:p>
         </p:txBody>
@@ -11894,7 +11894,7 @@
                 <a:ea typeface="Meiryo"/>
                 <a:cs typeface="Meiryo"/>
               </a:rPr>
-              <a:t>紙・劣化リスク</a:t>
+              <a:t>属人化・退職リスク</a:t>
             </a:r>
           </a:p>
         </p:txBody>
@@ -11938,7 +11938,7 @@
                 <a:ea typeface="Meiryo"/>
                 <a:cs typeface="Meiryo"/>
               </a:rPr>
-              <a:t>図面・契約書の紙原本は劣化・紛失・災害に弱い</a:t>
+              <a:t>“あの人しか知らない”状態。ベテラン退職で情報ごと失われる</a:t>
             </a:r>
           </a:p>
         </p:txBody>
@@ -12030,7 +12030,7 @@
                 <a:ea typeface="Meiryo"/>
                 <a:cs typeface="Meiryo"/>
               </a:rPr>
-              <a:t>⚖️</a:t>
+              <a:t>📑</a:t>
             </a:r>
           </a:p>
         </p:txBody>
@@ -12074,7 +12074,7 @@
                 <a:ea typeface="Meiryo"/>
                 <a:cs typeface="Meiryo"/>
               </a:rPr>
-              <a:t>個人情報の管理不安</a:t>
+              <a:t>紙・劣化リスク</a:t>
             </a:r>
           </a:p>
         </p:txBody>
@@ -12118,7 +12118,7 @@
                 <a:ea typeface="Meiryo"/>
                 <a:cs typeface="Meiryo"/>
               </a:rPr>
-              <a:t>どこに誰の情報があるか把握しきれず、漏えい・コンプラのリスク</a:t>
+              <a:t>図面・見積・施工写真の紙/個別保存は劣化・紛失・災害に弱い</a:t>
             </a:r>
           </a:p>
         </p:txBody>
@@ -12210,7 +12210,7 @@
                 <a:ea typeface="Meiryo"/>
                 <a:cs typeface="Meiryo"/>
               </a:rPr>
-              <a:t>🔁</a:t>
+              <a:t>⚖️</a:t>
             </a:r>
           </a:p>
         </p:txBody>
@@ -12254,7 +12254,7 @@
                 <a:ea typeface="Meiryo"/>
                 <a:cs typeface="Meiryo"/>
               </a:rPr>
-              <a:t>再利用できない</a:t>
+              <a:t>個人情報の管理不安</a:t>
             </a:r>
           </a:p>
         </p:txBody>
@@ -12298,7 +12298,7 @@
                 <a:ea typeface="Meiryo"/>
                 <a:cs typeface="Meiryo"/>
               </a:rPr>
-              <a:t>せっかくの設計ノウハウが次の提案・営業に活かしきれていない</a:t>
+              <a:t>個人宅オーナーの情報がどこに散在するか把握しきれず、漏えい・コンプラのリスク</a:t>
             </a:r>
           </a:p>
         </p:txBody>
@@ -12478,7 +12478,7 @@
                 <a:ea typeface="Meiryo"/>
                 <a:cs typeface="Meiryo"/>
               </a:rPr>
-              <a:t>相続・売買・リフォーム相談での即応力が、そのまま受注力になる</a:t>
+              <a:t>塗り替え・メンテ・改修相談での即応力が、そのまま受注力になる</a:t>
             </a:r>
           </a:p>
         </p:txBody>
@@ -13030,7 +13030,7 @@
                 <a:ea typeface="Meiryo"/>
                 <a:cs typeface="Meiryo"/>
               </a:rPr>
-              <a:t>紙図面・PDF・契約書・顧客台帳をスキャン／集約</a:t>
+              <a:t>紙図面・PDF・見積書・施工写真・顧客台帳をスキャン／集約</a:t>
             </a:r>
           </a:p>
         </p:txBody>
@@ -13256,7 +13256,7 @@
                 <a:ea typeface="Meiryo"/>
                 <a:cs typeface="Meiryo"/>
               </a:rPr>
-              <a:t>AI-OCR＋抽出で、図面メタ情報と個人情報をテキスト化・項目化</a:t>
+              <a:t>AI-OCR＋抽出で、図面・施工メタ情報と個人情報をテキスト化・項目化</a:t>
             </a:r>
           </a:p>
         </p:txBody>
@@ -13708,7 +13708,7 @@
                 <a:ea typeface="Meiryo"/>
                 <a:cs typeface="Meiryo"/>
               </a:rPr>
-              <a:t>物件 × 設計 × 顧客 を関連づけ、検索可能なデータベースへ</a:t>
+              <a:t>現場 × 設計 × 顧客 を関連づけ、検索可能なデータベースへ</a:t>
             </a:r>
           </a:p>
         </p:txBody>
@@ -13809,7 +13809,7 @@
                 <a:ea typeface="Meiryo"/>
                 <a:cs typeface="Meiryo"/>
               </a:rPr>
-              <a:t>「○○町の過去設計を見せて」「この顧客の取引履歴は？」に、社員の誰もが数秒で答えられる状態。</a:t>
+              <a:t>「あの現場の前回塗装は？」「この顧客の施工履歴は？」に、社員の誰もが数秒で答えられる状態。</a:t>
             </a:r>
           </a:p>
         </p:txBody>
@@ -15309,7 +15309,7 @@
                 <a:ea typeface="Meiryo"/>
                 <a:cs typeface="Meiryo"/>
               </a:rPr>
-              <a:t>個人情報保護法・宅建業法の要件に沿った取得・利用・保管・廃棄のルール整備</a:t>
+              <a:t>個人情報保護法・建設業法等の要件に沿った取得・利用・保管・廃棄のルール整備</a:t>
             </a:r>
           </a:p>
         </p:txBody>
@@ -17221,7 +17221,7 @@
                 <a:ea typeface="Meiryo"/>
                 <a:cs typeface="Meiryo"/>
               </a:rPr>
-              <a:t>📝</a:t>
+              <a:t>🔁</a:t>
             </a:r>
           </a:p>
         </p:txBody>
@@ -17265,7 +17265,7 @@
                 <a:ea typeface="Meiryo"/>
                 <a:cs typeface="Meiryo"/>
               </a:rPr>
-              <a:t>物件紹介文の自動生成</a:t>
+              <a:t>塗り替え再提案リストの自動生成</a:t>
             </a:r>
           </a:p>
         </p:txBody>
@@ -17309,7 +17309,7 @@
                 <a:ea typeface="Meiryo"/>
                 <a:cs typeface="Meiryo"/>
               </a:rPr>
-              <a:t>物件データから広告・ポータル掲載文を自動作成</a:t>
+              <a:t>施工履歴から“そろそろ塗り替え時期”の顧客を抽出し、案内文を自動作成</a:t>
             </a:r>
           </a:p>
         </p:txBody>
@@ -17445,7 +17445,7 @@
                 <a:ea typeface="Meiryo"/>
                 <a:cs typeface="Meiryo"/>
               </a:rPr>
-              <a:t>重要事項説明書・契約書ドラフト</a:t>
+              <a:t>見積書・施工計画書ドラフト</a:t>
             </a:r>
           </a:p>
         </p:txBody>
@@ -17489,7 +17489,7 @@
                 <a:ea typeface="Meiryo"/>
                 <a:cs typeface="Meiryo"/>
               </a:rPr>
-              <a:t>ひな型＋物件情報から下書きを自動生成、確認は人が行う</a:t>
+              <a:t>ひな型＋現場情報から下書きを自動生成、確認は人が行う</a:t>
             </a:r>
           </a:p>
         </p:txBody>
@@ -17625,7 +17625,7 @@
                 <a:ea typeface="Meiryo"/>
                 <a:cs typeface="Meiryo"/>
               </a:rPr>
-              <a:t>図面からの情報抽出</a:t>
+              <a:t>図面・現調からの情報抽出</a:t>
             </a:r>
           </a:p>
         </p:txBody>
@@ -17669,7 +17669,7 @@
                 <a:ea typeface="Meiryo"/>
                 <a:cs typeface="Meiryo"/>
               </a:rPr>
-              <a:t>図面から面積・部屋数・仕様を読み取り、台帳へ自動入力</a:t>
+              <a:t>図面や現地調査メモから数量・仕様を読み取り、積算・台帳へ自動入力</a:t>
             </a:r>
           </a:p>
         </p:txBody>
@@ -17849,7 +17849,7 @@
                 <a:ea typeface="Meiryo"/>
                 <a:cs typeface="Meiryo"/>
               </a:rPr>
-              <a:t>過去物件・FAQをもとに、問い合わせへ即時ドラフト回答</a:t>
+              <a:t>過去施工・FAQをもとに、問い合わせへ即時ドラフト回答</a:t>
             </a:r>
           </a:p>
         </p:txBody>
@@ -17941,7 +17941,7 @@
                 <a:ea typeface="Meiryo"/>
                 <a:cs typeface="Meiryo"/>
               </a:rPr>
-              <a:t>🏗️</a:t>
+              <a:t>🖼️</a:t>
             </a:r>
           </a:p>
         </p:txBody>
@@ -17985,7 +17985,7 @@
                 <a:ea typeface="Meiryo"/>
                 <a:cs typeface="Meiryo"/>
               </a:rPr>
-              <a:t>設計ナレッジの再利用</a:t>
+              <a:t>施工事例・提案資料の自動生成</a:t>
             </a:r>
           </a:p>
         </p:txBody>
@@ -18029,7 +18029,7 @@
                 <a:ea typeface="Meiryo"/>
                 <a:cs typeface="Meiryo"/>
               </a:rPr>
-              <a:t>過去設計を検索し、新規提案・見積のたたき台に活用</a:t>
+              <a:t>施工写真とビフォーアフターから事例・提案資料を自動作成</a:t>
             </a:r>
           </a:p>
         </p:txBody>
@@ -18209,7 +18209,7 @@
                 <a:ea typeface="Meiryo"/>
                 <a:cs typeface="Meiryo"/>
               </a:rPr>
-              <a:t>設計×顧客×物件を横断して“聞けば返ってくる”状態に</a:t>
+              <a:t>設計×顧客×現場を横断して“聞けば返ってくる”状態に</a:t>
             </a:r>
           </a:p>
         </p:txBody>

</xml_diff>